<commit_message>
config, migration and seeding
</commit_message>
<xml_diff>
--- a/postgres-migration-dasar/postgres-migration-dasar.pptx
+++ b/postgres-migration-dasar/postgres-migration-dasar.pptx
@@ -16,9 +16,10 @@
     <p:sldId id="264" r:id="rId10"/>
     <p:sldId id="265" r:id="rId11"/>
     <p:sldId id="266" r:id="rId12"/>
+    <p:sldId id="267" r:id="rId13"/>
   </p:sldIdLst>
   <p:notesMasterIdLst>
-    <p:notesMasterId r:id="rId13"/>
+    <p:notesMasterId r:id="rId14"/>
   </p:notesMasterIdLst>
   <p:sldSz cx="12192000" cy="6858000"/>
   <p:notesSz cx="6858000" cy="12192000"/>
@@ -712,6 +713,94 @@
             <a:fld id="{F7021451-1387-4CA6-816F-3879F97B5CBC}" type="slidenum">
               <a:rPr lang="en-US"/>
               <a:t>11</a:t>
+            </a:fld>
+            <a:endParaRPr lang="en-US"/>
+          </a:p>
+        </p:txBody>
+      </p:sp>
+    </p:spTree>
+    <p:extLst>
+      <p:ext uri="{BB962C8B-B14F-4D97-AF65-F5344CB8AC3E}">
+        <p14:creationId xmlns:p14="http://schemas.microsoft.com/office/powerpoint/2010/main" val="1024086991"/>
+      </p:ext>
+    </p:extLst>
+  </p:cSld>
+  <p:clrMapOvr>
+    <a:masterClrMapping/>
+  </p:clrMapOvr>
+</p:notes>
+</file>
+
+<file path=ppt/notesSlides/notesSlide12.xml><?xml version="1.0" encoding="utf-8"?>
+<p:notes xmlns:a="http://schemas.openxmlformats.org/drawingml/2006/main" xmlns:r="http://schemas.openxmlformats.org/officeDocument/2006/relationships" xmlns:p="http://schemas.openxmlformats.org/presentationml/2006/main">
+  <p:cSld>
+    <p:spTree>
+      <p:nvGrpSpPr>
+        <p:cNvPr id="1" name=""/>
+        <p:cNvGrpSpPr/>
+        <p:nvPr/>
+      </p:nvGrpSpPr>
+      <p:grpSpPr>
+        <a:xfrm>
+          <a:off x="0" y="0"/>
+          <a:ext cx="0" cy="0"/>
+          <a:chOff x="0" y="0"/>
+          <a:chExt cx="0" cy="0"/>
+        </a:xfrm>
+      </p:grpSpPr>
+      <p:sp>
+        <p:nvSpPr>
+          <p:cNvPr id="2" name="Slide Image Placeholder 1"/>
+          <p:cNvSpPr>
+            <a:spLocks noGrp="1" noRot="1" noChangeAspect="1"/>
+          </p:cNvSpPr>
+          <p:nvPr>
+            <p:ph type="sldImg"/>
+          </p:nvPr>
+        </p:nvSpPr>
+        <p:spPr/>
+      </p:sp>
+      <p:sp>
+        <p:nvSpPr>
+          <p:cNvPr id="3" name="Notes Placeholder 2"/>
+          <p:cNvSpPr>
+            <a:spLocks noGrp="1"/>
+          </p:cNvSpPr>
+          <p:nvPr>
+            <p:ph type="body" idx="1"/>
+          </p:nvPr>
+        </p:nvSpPr>
+        <p:spPr/>
+        <p:txBody>
+          <a:bodyPr/>
+          <a:lstStyle/>
+          <a:p>
+            <a:r>
+              <a:rPr lang="en-US" dirty="0"/>
+              <a:t/>
+            </a:r>
+            <a:endParaRPr lang="en-US" dirty="0"/>
+          </a:p>
+        </p:txBody>
+      </p:sp>
+      <p:sp>
+        <p:nvSpPr>
+          <p:cNvPr id="4" name="Slide Number Placeholder 3"/>
+          <p:cNvSpPr>
+            <a:spLocks noGrp="1"/>
+          </p:cNvSpPr>
+          <p:nvPr>
+            <p:ph type="sldNum" sz="quarter" idx="10"/>
+          </p:nvPr>
+        </p:nvSpPr>
+        <p:spPr/>
+        <p:txBody>
+          <a:bodyPr/>
+          <a:lstStyle/>
+          <a:p>
+            <a:fld id="{F7021451-1387-4CA6-816F-3879F97B5CBC}" type="slidenum">
+              <a:rPr lang="en-US"/>
+              <a:t>12</a:t>
             </a:fld>
             <a:endParaRPr lang="en-US"/>
           </a:p>
@@ -1915,7 +2004,7 @@
         <p:spPr>
           <a:xfrm>
             <a:off x="548640" y="4526280"/>
-            <a:ext cx="8229600" cy="822960"/>
+            <a:ext cx="8503920" cy="822960"/>
           </a:xfrm>
           <a:prstGeom prst="rect">
             <a:avLst/>
@@ -1942,7 +2031,7 @@
                 <a:ea typeface="Calibri" pitchFamily="34" charset="-122"/>
                 <a:cs typeface="Calibri" pitchFamily="34" charset="-120"/>
               </a:rPr>
-              <a:t>Dari psql manual ke kode yang ngobrol sendiri ke database — dan cara</a:t>
+              <a:t>Dari psql manual ke kode yang ngobrol sendiri ke database — cara ngatur</a:t>
             </a:r>
             <a:endParaRPr lang="en-US" sz="1450" dirty="0"/>
           </a:p>
@@ -1962,7 +2051,7 @@
                 <a:ea typeface="Calibri" pitchFamily="34" charset="-122"/>
                 <a:cs typeface="Calibri" pitchFamily="34" charset="-120"/>
               </a:rPr>
-              <a:t>ngatur perubahan struktur database biar gak cuma nempel di satu laptop.</a:t>
+              <a:t>perubahan struktur database, sampai ngisi data contoh (seeding) buat development.</a:t>
             </a:r>
             <a:endParaRPr lang="en-US" sz="1450" dirty="0"/>
           </a:p>
@@ -2138,7 +2227,7 @@
                 <a:ea typeface="Calibri" pitchFamily="34" charset="-122"/>
                 <a:cs typeface="Calibri" pitchFamily="34" charset="-120"/>
               </a:rPr>
-              <a:t>04 · RINGKASAN</a:t>
+              <a:t>04 · SEEDING</a:t>
             </a:r>
             <a:endParaRPr lang="en-US" sz="1300" dirty="0"/>
           </a:p>
@@ -2177,7 +2266,7 @@
                 <a:ea typeface="Cambria" pitchFamily="34" charset="-122"/>
                 <a:cs typeface="Cambria" pitchFamily="34" charset="-120"/>
               </a:rPr>
-              <a:t>Istilah yang Sudah Dikuasai</a:t>
+              <a:t>Seeding — Data Contoh buat Development</a:t>
             </a:r>
             <a:endParaRPr lang="en-US" sz="3000" dirty="0"/>
           </a:p>
@@ -2191,12 +2280,409 @@
         </p:nvSpPr>
         <p:spPr>
           <a:xfrm>
-            <a:off x="548640" y="1691640"/>
-            <a:ext cx="11094415" cy="3392424"/>
+            <a:off x="10865815" y="658368"/>
+            <a:ext cx="777240" cy="777240"/>
+          </a:xfrm>
+          <a:prstGeom prst="ellipse">
+            <a:avLst/>
+          </a:prstGeom>
+          <a:solidFill>
+            <a:srgbClr val="E3F7F4"/>
+          </a:solidFill>
+          <a:ln/>
+        </p:spPr>
+      </p:sp>
+      <p:pic>
+        <p:nvPicPr>
+          <p:cNvPr id="5" name="Image 0" descr="preencoded.png">    </p:cNvPr>
+          <p:cNvPicPr>
+            <a:picLocks noChangeAspect="1"/>
+          </p:cNvPicPr>
+          <p:nvPr/>
+        </p:nvPicPr>
+        <p:blipFill>
+          <a:blip r:embed="rId1"/>
+          <a:stretch>
+            <a:fillRect/>
+          </a:stretch>
+        </p:blipFill>
+        <p:spPr>
+          <a:xfrm>
+            <a:off x="11052353" y="844906"/>
+            <a:ext cx="404165" cy="404165"/>
+          </a:xfrm>
+          <a:prstGeom prst="rect">
+            <a:avLst/>
+          </a:prstGeom>
+        </p:spPr>
+      </p:pic>
+      <p:sp>
+        <p:nvSpPr>
+          <p:cNvPr id="6" name="Shape 3"/>
+          <p:cNvSpPr/>
+          <p:nvPr/>
+        </p:nvSpPr>
+        <p:spPr>
+          <a:xfrm>
+            <a:off x="548640" y="1737360"/>
+            <a:ext cx="5623560" cy="4206240"/>
           </a:xfrm>
           <a:prstGeom prst="roundRect">
             <a:avLst>
-              <a:gd name="adj" fmla="val 2156"/>
+              <a:gd name="adj" fmla="val 1957"/>
+            </a:avLst>
+          </a:prstGeom>
+          <a:solidFill>
+            <a:srgbClr val="0B1929"/>
+          </a:solidFill>
+          <a:ln/>
+          <a:effectLst>
+            <a:outerShdw sx="100000" sy="100000" kx="0" ky="0" algn="bl" rotWithShape="0" blurRad="127000" dist="38100" dir="5400000">
+              <a:srgbClr val="0B1929">
+                <a:alpha val="35000"/>
+              </a:srgbClr>
+            </a:outerShdw>
+          </a:effectLst>
+        </p:spPr>
+      </p:sp>
+      <p:sp>
+        <p:nvSpPr>
+          <p:cNvPr id="7" name="Shape 4"/>
+          <p:cNvSpPr/>
+          <p:nvPr/>
+        </p:nvSpPr>
+        <p:spPr>
+          <a:xfrm>
+            <a:off x="713232" y="1883664"/>
+            <a:ext cx="100584" cy="100584"/>
+          </a:xfrm>
+          <a:prstGeom prst="ellipse">
+            <a:avLst/>
+          </a:prstGeom>
+          <a:solidFill>
+            <a:srgbClr val="E8626B"/>
+          </a:solidFill>
+          <a:ln/>
+        </p:spPr>
+      </p:sp>
+      <p:sp>
+        <p:nvSpPr>
+          <p:cNvPr id="8" name="Shape 5"/>
+          <p:cNvSpPr/>
+          <p:nvPr/>
+        </p:nvSpPr>
+        <p:spPr>
+          <a:xfrm>
+            <a:off x="877824" y="1883664"/>
+            <a:ext cx="100584" cy="100584"/>
+          </a:xfrm>
+          <a:prstGeom prst="ellipse">
+            <a:avLst/>
+          </a:prstGeom>
+          <a:solidFill>
+            <a:srgbClr val="F2C14E"/>
+          </a:solidFill>
+          <a:ln/>
+        </p:spPr>
+      </p:sp>
+      <p:sp>
+        <p:nvSpPr>
+          <p:cNvPr id="9" name="Shape 6"/>
+          <p:cNvSpPr/>
+          <p:nvPr/>
+        </p:nvSpPr>
+        <p:spPr>
+          <a:xfrm>
+            <a:off x="1042416" y="1883664"/>
+            <a:ext cx="100584" cy="100584"/>
+          </a:xfrm>
+          <a:prstGeom prst="ellipse">
+            <a:avLst/>
+          </a:prstGeom>
+          <a:solidFill>
+            <a:srgbClr val="5FD07C"/>
+          </a:solidFill>
+          <a:ln/>
+        </p:spPr>
+      </p:sp>
+      <p:sp>
+        <p:nvSpPr>
+          <p:cNvPr id="10" name="Text 7"/>
+          <p:cNvSpPr/>
+          <p:nvPr/>
+        </p:nvSpPr>
+        <p:spPr>
+          <a:xfrm>
+            <a:off x="804672" y="2121408"/>
+            <a:ext cx="5111496" cy="3657600"/>
+          </a:xfrm>
+          <a:prstGeom prst="rect">
+            <a:avLst/>
+          </a:prstGeom>
+          <a:noFill/>
+          <a:ln/>
+        </p:spPr>
+        <p:txBody>
+          <a:bodyPr wrap="square" lIns="0" tIns="0" rIns="0" bIns="0" rtlCol="0" anchor="t"/>
+          <a:lstStyle/>
+          <a:p>
+            <a:pPr indent="0" marL="0">
+              <a:lnSpc>
+                <a:spcPct val="112000"/>
+              </a:lnSpc>
+              <a:spcAft>
+                <a:spcPts val="400"/>
+              </a:spcAft>
+              <a:buNone/>
+            </a:pPr>
+            <a:r>
+              <a:rPr lang="en-US" sz="1200" dirty="0">
+                <a:solidFill>
+                  <a:srgbClr val="8FE3C7"/>
+                </a:solidFill>
+                <a:latin typeface="Courier New" pitchFamily="34" charset="0"/>
+                <a:ea typeface="Courier New" pitchFamily="34" charset="-122"/>
+                <a:cs typeface="Courier New" pitchFamily="34" charset="-120"/>
+              </a:rPr>
+              <a:t>async function seed() {</a:t>
+            </a:r>
+            <a:endParaRPr lang="en-US" sz="1200" dirty="0"/>
+          </a:p>
+          <a:p>
+            <a:pPr indent="0" marL="0">
+              <a:lnSpc>
+                <a:spcPct val="112000"/>
+              </a:lnSpc>
+              <a:spcAft>
+                <a:spcPts val="400"/>
+              </a:spcAft>
+              <a:buNone/>
+            </a:pPr>
+            <a:r>
+              <a:rPr lang="en-US" sz="1200" dirty="0">
+                <a:solidFill>
+                  <a:srgbClr val="8FE3C7"/>
+                </a:solidFill>
+                <a:latin typeface="Courier New" pitchFamily="34" charset="0"/>
+                <a:ea typeface="Courier New" pitchFamily="34" charset="-122"/>
+                <a:cs typeface="Courier New" pitchFamily="34" charset="-120"/>
+              </a:rPr>
+              <a:t>  await pool.query("DELETE FROM buku");</a:t>
+            </a:r>
+            <a:endParaRPr lang="en-US" sz="1200" dirty="0"/>
+          </a:p>
+          <a:p>
+            <a:pPr indent="0" marL="0">
+              <a:lnSpc>
+                <a:spcPct val="112000"/>
+              </a:lnSpc>
+              <a:spcAft>
+                <a:spcPts val="400"/>
+              </a:spcAft>
+              <a:buNone/>
+            </a:pPr>
+            <a:endParaRPr lang="en-US" sz="1200" dirty="0"/>
+          </a:p>
+          <a:p>
+            <a:pPr indent="0" marL="0">
+              <a:lnSpc>
+                <a:spcPct val="112000"/>
+              </a:lnSpc>
+              <a:spcAft>
+                <a:spcPts val="400"/>
+              </a:spcAft>
+              <a:buNone/>
+            </a:pPr>
+            <a:r>
+              <a:rPr lang="en-US" sz="1200" dirty="0">
+                <a:solidFill>
+                  <a:srgbClr val="8FE3C7"/>
+                </a:solidFill>
+                <a:latin typeface="Courier New" pitchFamily="34" charset="0"/>
+                <a:ea typeface="Courier New" pitchFamily="34" charset="-122"/>
+                <a:cs typeface="Courier New" pitchFamily="34" charset="-120"/>
+              </a:rPr>
+              <a:t>  for (const buku of daftarBuku) {</a:t>
+            </a:r>
+            <a:endParaRPr lang="en-US" sz="1200" dirty="0"/>
+          </a:p>
+          <a:p>
+            <a:pPr indent="0" marL="0">
+              <a:lnSpc>
+                <a:spcPct val="112000"/>
+              </a:lnSpc>
+              <a:spcAft>
+                <a:spcPts val="400"/>
+              </a:spcAft>
+              <a:buNone/>
+            </a:pPr>
+            <a:r>
+              <a:rPr lang="en-US" sz="1200" dirty="0">
+                <a:solidFill>
+                  <a:srgbClr val="8FE3C7"/>
+                </a:solidFill>
+                <a:latin typeface="Courier New" pitchFamily="34" charset="0"/>
+                <a:ea typeface="Courier New" pitchFamily="34" charset="-122"/>
+                <a:cs typeface="Courier New" pitchFamily="34" charset="-120"/>
+              </a:rPr>
+              <a:t>    await pool.query(</a:t>
+            </a:r>
+            <a:endParaRPr lang="en-US" sz="1200" dirty="0"/>
+          </a:p>
+          <a:p>
+            <a:pPr indent="0" marL="0">
+              <a:lnSpc>
+                <a:spcPct val="112000"/>
+              </a:lnSpc>
+              <a:spcAft>
+                <a:spcPts val="400"/>
+              </a:spcAft>
+              <a:buNone/>
+            </a:pPr>
+            <a:r>
+              <a:rPr lang="en-US" sz="1200" dirty="0">
+                <a:solidFill>
+                  <a:srgbClr val="8FE3C7"/>
+                </a:solidFill>
+                <a:latin typeface="Courier New" pitchFamily="34" charset="0"/>
+                <a:ea typeface="Courier New" pitchFamily="34" charset="-122"/>
+                <a:cs typeface="Courier New" pitchFamily="34" charset="-120"/>
+              </a:rPr>
+              <a:t>      "INSERT INTO buku (judul, penulis)</a:t>
+            </a:r>
+            <a:endParaRPr lang="en-US" sz="1200" dirty="0"/>
+          </a:p>
+          <a:p>
+            <a:pPr indent="0" marL="0">
+              <a:lnSpc>
+                <a:spcPct val="112000"/>
+              </a:lnSpc>
+              <a:spcAft>
+                <a:spcPts val="400"/>
+              </a:spcAft>
+              <a:buNone/>
+            </a:pPr>
+            <a:r>
+              <a:rPr lang="en-US" sz="1200" dirty="0">
+                <a:solidFill>
+                  <a:srgbClr val="8FE3C7"/>
+                </a:solidFill>
+                <a:latin typeface="Courier New" pitchFamily="34" charset="0"/>
+                <a:ea typeface="Courier New" pitchFamily="34" charset="-122"/>
+                <a:cs typeface="Courier New" pitchFamily="34" charset="-120"/>
+              </a:rPr>
+              <a:t>        VALUES ($1, $2)",</a:t>
+            </a:r>
+            <a:endParaRPr lang="en-US" sz="1200" dirty="0"/>
+          </a:p>
+          <a:p>
+            <a:pPr indent="0" marL="0">
+              <a:lnSpc>
+                <a:spcPct val="112000"/>
+              </a:lnSpc>
+              <a:spcAft>
+                <a:spcPts val="400"/>
+              </a:spcAft>
+              <a:buNone/>
+            </a:pPr>
+            <a:r>
+              <a:rPr lang="en-US" sz="1200" dirty="0">
+                <a:solidFill>
+                  <a:srgbClr val="8FE3C7"/>
+                </a:solidFill>
+                <a:latin typeface="Courier New" pitchFamily="34" charset="0"/>
+                <a:ea typeface="Courier New" pitchFamily="34" charset="-122"/>
+                <a:cs typeface="Courier New" pitchFamily="34" charset="-120"/>
+              </a:rPr>
+              <a:t>      [buku.judul, buku.penulis]</a:t>
+            </a:r>
+            <a:endParaRPr lang="en-US" sz="1200" dirty="0"/>
+          </a:p>
+          <a:p>
+            <a:pPr indent="0" marL="0">
+              <a:lnSpc>
+                <a:spcPct val="112000"/>
+              </a:lnSpc>
+              <a:spcAft>
+                <a:spcPts val="400"/>
+              </a:spcAft>
+              <a:buNone/>
+            </a:pPr>
+            <a:r>
+              <a:rPr lang="en-US" sz="1200" dirty="0">
+                <a:solidFill>
+                  <a:srgbClr val="8FE3C7"/>
+                </a:solidFill>
+                <a:latin typeface="Courier New" pitchFamily="34" charset="0"/>
+                <a:ea typeface="Courier New" pitchFamily="34" charset="-122"/>
+                <a:cs typeface="Courier New" pitchFamily="34" charset="-120"/>
+              </a:rPr>
+              <a:t>    );</a:t>
+            </a:r>
+            <a:endParaRPr lang="en-US" sz="1200" dirty="0"/>
+          </a:p>
+          <a:p>
+            <a:pPr indent="0" marL="0">
+              <a:lnSpc>
+                <a:spcPct val="112000"/>
+              </a:lnSpc>
+              <a:spcAft>
+                <a:spcPts val="400"/>
+              </a:spcAft>
+              <a:buNone/>
+            </a:pPr>
+            <a:r>
+              <a:rPr lang="en-US" sz="1200" dirty="0">
+                <a:solidFill>
+                  <a:srgbClr val="8FE3C7"/>
+                </a:solidFill>
+                <a:latin typeface="Courier New" pitchFamily="34" charset="0"/>
+                <a:ea typeface="Courier New" pitchFamily="34" charset="-122"/>
+                <a:cs typeface="Courier New" pitchFamily="34" charset="-120"/>
+              </a:rPr>
+              <a:t>  }</a:t>
+            </a:r>
+            <a:endParaRPr lang="en-US" sz="1200" dirty="0"/>
+          </a:p>
+          <a:p>
+            <a:pPr indent="0" marL="0">
+              <a:lnSpc>
+                <a:spcPct val="112000"/>
+              </a:lnSpc>
+              <a:spcAft>
+                <a:spcPts val="400"/>
+              </a:spcAft>
+              <a:buNone/>
+            </a:pPr>
+            <a:r>
+              <a:rPr lang="en-US" sz="1200" dirty="0">
+                <a:solidFill>
+                  <a:srgbClr val="8FE3C7"/>
+                </a:solidFill>
+                <a:latin typeface="Courier New" pitchFamily="34" charset="0"/>
+                <a:ea typeface="Courier New" pitchFamily="34" charset="-122"/>
+                <a:cs typeface="Courier New" pitchFamily="34" charset="-120"/>
+              </a:rPr>
+              <a:t>}</a:t>
+            </a:r>
+            <a:endParaRPr lang="en-US" sz="1200" dirty="0"/>
+          </a:p>
+        </p:txBody>
+      </p:sp>
+      <p:sp>
+        <p:nvSpPr>
+          <p:cNvPr id="11" name="Shape 8"/>
+          <p:cNvSpPr/>
+          <p:nvPr/>
+        </p:nvSpPr>
+        <p:spPr>
+          <a:xfrm>
+            <a:off x="6355080" y="1737360"/>
+            <a:ext cx="5257800" cy="2148840"/>
+          </a:xfrm>
+          <a:prstGeom prst="roundRect">
+            <a:avLst>
+              <a:gd name="adj" fmla="val 4255"/>
             </a:avLst>
           </a:prstGeom>
           <a:solidFill>
@@ -2217,9 +2703,459 @@
           </a:effectLst>
         </p:spPr>
       </p:sp>
+      <p:sp>
+        <p:nvSpPr>
+          <p:cNvPr id="12" name="Text 9"/>
+          <p:cNvSpPr/>
+          <p:nvPr/>
+        </p:nvSpPr>
+        <p:spPr>
+          <a:xfrm>
+            <a:off x="6629400" y="1965960"/>
+            <a:ext cx="4709160" cy="365760"/>
+          </a:xfrm>
+          <a:prstGeom prst="rect">
+            <a:avLst/>
+          </a:prstGeom>
+          <a:noFill/>
+          <a:ln/>
+        </p:spPr>
+        <p:txBody>
+          <a:bodyPr wrap="square" lIns="0" tIns="0" rIns="0" bIns="0" rtlCol="0" anchor="ctr"/>
+          <a:lstStyle/>
+          <a:p>
+            <a:pPr indent="0" marL="0">
+              <a:buNone/>
+            </a:pPr>
+            <a:r>
+              <a:rPr lang="en-US" sz="1400" b="1" dirty="0">
+                <a:solidFill>
+                  <a:srgbClr val="2EC4B6"/>
+                </a:solidFill>
+                <a:latin typeface="Cambria" pitchFamily="34" charset="0"/>
+                <a:ea typeface="Cambria" pitchFamily="34" charset="-122"/>
+                <a:cs typeface="Cambria" pitchFamily="34" charset="-120"/>
+              </a:rPr>
+              <a:t>Cara Ngomonginnya</a:t>
+            </a:r>
+            <a:endParaRPr lang="en-US" sz="1400" dirty="0"/>
+          </a:p>
+        </p:txBody>
+      </p:sp>
+      <p:sp>
+        <p:nvSpPr>
+          <p:cNvPr id="13" name="Text 10"/>
+          <p:cNvSpPr/>
+          <p:nvPr/>
+        </p:nvSpPr>
+        <p:spPr>
+          <a:xfrm>
+            <a:off x="6629400" y="2377440"/>
+            <a:ext cx="4709160" cy="1417320"/>
+          </a:xfrm>
+          <a:prstGeom prst="rect">
+            <a:avLst/>
+          </a:prstGeom>
+          <a:noFill/>
+          <a:ln/>
+        </p:spPr>
+        <p:txBody>
+          <a:bodyPr wrap="square" lIns="0" tIns="0" rIns="0" bIns="0" rtlCol="0" anchor="t"/>
+          <a:lstStyle/>
+          <a:p>
+            <a:pPr indent="0" marL="0">
+              <a:lnSpc>
+                <a:spcPct val="130000"/>
+              </a:lnSpc>
+              <a:buNone/>
+            </a:pPr>
+            <a:r>
+              <a:rPr lang="en-US" sz="1300" i="1" dirty="0">
+                <a:solidFill>
+                  <a:srgbClr val="10243E"/>
+                </a:solidFill>
+                <a:latin typeface="Cambria" pitchFamily="34" charset="0"/>
+                <a:ea typeface="Cambria" pitchFamily="34" charset="-122"/>
+                <a:cs typeface="Cambria" pitchFamily="34" charset="-120"/>
+              </a:rPr>
+              <a:t>“Migration itu bikin rak KOSONG yang strukturnya bener. Seed itu isi rak itu sama barang CONTOH buat latihan. Makanya seed SELALU hapus dulu isinya sebelum isi ulang — biar gak numpuk.”</a:t>
+            </a:r>
+            <a:endParaRPr lang="en-US" sz="1300" dirty="0"/>
+          </a:p>
+        </p:txBody>
+      </p:sp>
+      <p:sp>
+        <p:nvSpPr>
+          <p:cNvPr id="14" name="Shape 11"/>
+          <p:cNvSpPr/>
+          <p:nvPr/>
+        </p:nvSpPr>
+        <p:spPr>
+          <a:xfrm>
+            <a:off x="6355080" y="4069080"/>
+            <a:ext cx="5257800" cy="2377440"/>
+          </a:xfrm>
+          <a:prstGeom prst="roundRect">
+            <a:avLst>
+              <a:gd name="adj" fmla="val 3846"/>
+            </a:avLst>
+          </a:prstGeom>
+          <a:solidFill>
+            <a:srgbClr val="E3F7F4"/>
+          </a:solidFill>
+          <a:ln/>
+        </p:spPr>
+      </p:sp>
+      <p:sp>
+        <p:nvSpPr>
+          <p:cNvPr id="15" name="Shape 12"/>
+          <p:cNvSpPr/>
+          <p:nvPr/>
+        </p:nvSpPr>
+        <p:spPr>
+          <a:xfrm>
+            <a:off x="6629400" y="4297680"/>
+            <a:ext cx="502920" cy="502920"/>
+          </a:xfrm>
+          <a:prstGeom prst="ellipse">
+            <a:avLst/>
+          </a:prstGeom>
+          <a:solidFill>
+            <a:srgbClr val="FFFFFF"/>
+          </a:solidFill>
+          <a:ln/>
+        </p:spPr>
+      </p:sp>
+      <p:pic>
+        <p:nvPicPr>
+          <p:cNvPr id="16" name="Image 1" descr="preencoded.png">    </p:cNvPr>
+          <p:cNvPicPr>
+            <a:picLocks noChangeAspect="1"/>
+          </p:cNvPicPr>
+          <p:nvPr/>
+        </p:nvPicPr>
+        <p:blipFill>
+          <a:blip r:embed="rId2"/>
+          <a:stretch>
+            <a:fillRect/>
+          </a:stretch>
+        </p:blipFill>
+        <p:spPr>
+          <a:xfrm>
+            <a:off x="6735013" y="4403293"/>
+            <a:ext cx="291694" cy="291694"/>
+          </a:xfrm>
+          <a:prstGeom prst="rect">
+            <a:avLst/>
+          </a:prstGeom>
+        </p:spPr>
+      </p:pic>
+      <p:sp>
+        <p:nvSpPr>
+          <p:cNvPr id="17" name="Text 13"/>
+          <p:cNvSpPr/>
+          <p:nvPr/>
+        </p:nvSpPr>
+        <p:spPr>
+          <a:xfrm>
+            <a:off x="7269480" y="4315968"/>
+            <a:ext cx="4114800" cy="457200"/>
+          </a:xfrm>
+          <a:prstGeom prst="rect">
+            <a:avLst/>
+          </a:prstGeom>
+          <a:noFill/>
+          <a:ln/>
+        </p:spPr>
+        <p:txBody>
+          <a:bodyPr wrap="square" lIns="0" tIns="0" rIns="0" bIns="0" rtlCol="0" anchor="ctr"/>
+          <a:lstStyle/>
+          <a:p>
+            <a:pPr indent="0" marL="0">
+              <a:buNone/>
+            </a:pPr>
+            <a:r>
+              <a:rPr lang="en-US" sz="1450" b="1" dirty="0">
+                <a:solidFill>
+                  <a:srgbClr val="10243E"/>
+                </a:solidFill>
+                <a:latin typeface="Cambria" pitchFamily="34" charset="0"/>
+                <a:ea typeface="Cambria" pitchFamily="34" charset="-122"/>
+                <a:cs typeface="Cambria" pitchFamily="34" charset="-120"/>
+              </a:rPr>
+              <a:t>Kenapa Manual Dulu, Baru AI?</a:t>
+            </a:r>
+            <a:endParaRPr lang="en-US" sz="1450" dirty="0"/>
+          </a:p>
+        </p:txBody>
+      </p:sp>
+      <p:sp>
+        <p:nvSpPr>
+          <p:cNvPr id="18" name="Text 14"/>
+          <p:cNvSpPr/>
+          <p:nvPr/>
+        </p:nvSpPr>
+        <p:spPr>
+          <a:xfrm>
+            <a:off x="6629400" y="4937760"/>
+            <a:ext cx="4709160" cy="1371600"/>
+          </a:xfrm>
+          <a:prstGeom prst="rect">
+            <a:avLst/>
+          </a:prstGeom>
+          <a:noFill/>
+          <a:ln/>
+        </p:spPr>
+        <p:txBody>
+          <a:bodyPr wrap="square" lIns="0" tIns="0" rIns="0" bIns="0" rtlCol="0" anchor="t"/>
+          <a:lstStyle/>
+          <a:p>
+            <a:pPr indent="0" marL="0">
+              <a:lnSpc>
+                <a:spcPct val="130000"/>
+              </a:lnSpc>
+              <a:buNone/>
+            </a:pPr>
+            <a:r>
+              <a:rPr lang="en-US" sz="1250" dirty="0">
+                <a:solidFill>
+                  <a:srgbClr val="10243E"/>
+                </a:solidFill>
+                <a:latin typeface="Calibri" pitchFamily="34" charset="0"/>
+                <a:ea typeface="Calibri" pitchFamily="34" charset="-122"/>
+                <a:cs typeface="Calibri" pitchFamily="34" charset="-120"/>
+              </a:rPr>
+              <a:t>Nanti data seed yang lebih besar/variatif boleh di-generate pakai AI — TAPI cuma kalau kamu udah paham pola di atas. Tanpa itu, gampang lupa DELETE dulu (data numpuk terus), atau gak sadar query-nya rawan SQL Injection.</a:t>
+            </a:r>
+            <a:endParaRPr lang="en-US" sz="1250" dirty="0"/>
+          </a:p>
+        </p:txBody>
+      </p:sp>
+      <p:sp>
+        <p:nvSpPr>
+          <p:cNvPr id="19" name="Text 15"/>
+          <p:cNvSpPr/>
+          <p:nvPr/>
+        </p:nvSpPr>
+        <p:spPr>
+          <a:xfrm>
+            <a:off x="548640" y="6519672"/>
+            <a:ext cx="8229600" cy="274320"/>
+          </a:xfrm>
+          <a:prstGeom prst="rect">
+            <a:avLst/>
+          </a:prstGeom>
+          <a:noFill/>
+          <a:ln/>
+        </p:spPr>
+        <p:txBody>
+          <a:bodyPr wrap="square" lIns="0" tIns="0" rIns="0" bIns="0" rtlCol="0" anchor="ctr"/>
+          <a:lstStyle/>
+          <a:p>
+            <a:pPr indent="0" marL="0">
+              <a:buNone/>
+            </a:pPr>
+            <a:r>
+              <a:rPr lang="en-US" sz="900" dirty="0">
+                <a:solidFill>
+                  <a:srgbClr val="5C7A99"/>
+                </a:solidFill>
+                <a:latin typeface="Calibri" pitchFamily="34" charset="0"/>
+                <a:ea typeface="Calibri" pitchFamily="34" charset="-122"/>
+                <a:cs typeface="Calibri" pitchFamily="34" charset="-120"/>
+              </a:rPr>
+              <a:t>db.js, Parameterized Query, Migration &amp; Seeding</a:t>
+            </a:r>
+            <a:endParaRPr lang="en-US" sz="900" dirty="0"/>
+          </a:p>
+        </p:txBody>
+      </p:sp>
+      <p:sp>
+        <p:nvSpPr>
+          <p:cNvPr id="20" name="Text 16"/>
+          <p:cNvSpPr/>
+          <p:nvPr/>
+        </p:nvSpPr>
+        <p:spPr>
+          <a:xfrm>
+            <a:off x="11094415" y="6519672"/>
+            <a:ext cx="548640" cy="274320"/>
+          </a:xfrm>
+          <a:prstGeom prst="rect">
+            <a:avLst/>
+          </a:prstGeom>
+          <a:noFill/>
+          <a:ln/>
+        </p:spPr>
+        <p:txBody>
+          <a:bodyPr wrap="square" lIns="0" tIns="0" rIns="0" bIns="0" rtlCol="0" anchor="ctr"/>
+          <a:lstStyle/>
+          <a:p>
+            <a:pPr algn="r" indent="0" marL="0">
+              <a:buNone/>
+            </a:pPr>
+            <a:r>
+              <a:rPr lang="en-US" sz="900" dirty="0">
+                <a:solidFill>
+                  <a:srgbClr val="5C7A99"/>
+                </a:solidFill>
+                <a:latin typeface="Calibri" pitchFamily="34" charset="0"/>
+                <a:ea typeface="Calibri" pitchFamily="34" charset="-122"/>
+                <a:cs typeface="Calibri" pitchFamily="34" charset="-120"/>
+              </a:rPr>
+              <a:t>10</a:t>
+            </a:r>
+            <a:endParaRPr lang="en-US" sz="900" dirty="0"/>
+          </a:p>
+        </p:txBody>
+      </p:sp>
+    </p:spTree>
+  </p:cSld>
+  <p:clrMapOvr>
+    <a:masterClrMapping/>
+  </p:clrMapOvr>
+</p:sld>
+</file>
+
+<file path=ppt/slides/slide11.xml><?xml version="1.0" encoding="utf-8"?>
+<p:sld xmlns:a="http://schemas.openxmlformats.org/drawingml/2006/main" xmlns:r="http://schemas.openxmlformats.org/officeDocument/2006/relationships" xmlns:p="http://schemas.openxmlformats.org/presentationml/2006/main">
+  <p:cSld name="Slide 11">
+    <p:bg>
+      <p:bgPr>
+        <a:solidFill>
+          <a:srgbClr val="F4F8FA"/>
+        </a:solidFill>
+      </p:bgPr>
+    </p:bg>
+    <p:spTree>
+      <p:nvGrpSpPr>
+        <p:cNvPr id="1" name=""/>
+        <p:cNvGrpSpPr/>
+        <p:nvPr/>
+      </p:nvGrpSpPr>
+      <p:grpSpPr>
+        <a:xfrm>
+          <a:off x="0" y="0"/>
+          <a:ext cx="0" cy="0"/>
+          <a:chOff x="0" y="0"/>
+          <a:chExt cx="0" cy="0"/>
+        </a:xfrm>
+      </p:grpSpPr>
+      <p:sp>
+        <p:nvSpPr>
+          <p:cNvPr id="2" name="Text 0"/>
+          <p:cNvSpPr/>
+          <p:nvPr/>
+        </p:nvSpPr>
+        <p:spPr>
+          <a:xfrm>
+            <a:off x="548640" y="384048"/>
+            <a:ext cx="8229600" cy="320040"/>
+          </a:xfrm>
+          <a:prstGeom prst="rect">
+            <a:avLst/>
+          </a:prstGeom>
+          <a:noFill/>
+          <a:ln/>
+        </p:spPr>
+        <p:txBody>
+          <a:bodyPr wrap="square" lIns="0" tIns="0" rIns="0" bIns="0" rtlCol="0" anchor="ctr"/>
+          <a:lstStyle/>
+          <a:p>
+            <a:pPr indent="0" marL="0">
+              <a:buNone/>
+            </a:pPr>
+            <a:r>
+              <a:rPr lang="en-US" sz="1300" b="1" spc="200" kern="0" dirty="0">
+                <a:solidFill>
+                  <a:srgbClr val="2EC4B6"/>
+                </a:solidFill>
+                <a:latin typeface="Calibri" pitchFamily="34" charset="0"/>
+                <a:ea typeface="Calibri" pitchFamily="34" charset="-122"/>
+                <a:cs typeface="Calibri" pitchFamily="34" charset="-120"/>
+              </a:rPr>
+              <a:t>05 · RINGKASAN</a:t>
+            </a:r>
+            <a:endParaRPr lang="en-US" sz="1300" dirty="0"/>
+          </a:p>
+        </p:txBody>
+      </p:sp>
+      <p:sp>
+        <p:nvSpPr>
+          <p:cNvPr id="3" name="Text 1"/>
+          <p:cNvSpPr/>
+          <p:nvPr/>
+        </p:nvSpPr>
+        <p:spPr>
+          <a:xfrm>
+            <a:off x="548640" y="713232"/>
+            <a:ext cx="10180015" cy="822960"/>
+          </a:xfrm>
+          <a:prstGeom prst="rect">
+            <a:avLst/>
+          </a:prstGeom>
+          <a:noFill/>
+          <a:ln/>
+        </p:spPr>
+        <p:txBody>
+          <a:bodyPr wrap="square" lIns="0" tIns="0" rIns="0" bIns="0" rtlCol="0" anchor="ctr"/>
+          <a:lstStyle/>
+          <a:p>
+            <a:pPr indent="0" marL="0">
+              <a:buNone/>
+            </a:pPr>
+            <a:r>
+              <a:rPr lang="en-US" sz="3000" b="1" dirty="0">
+                <a:solidFill>
+                  <a:srgbClr val="10243E"/>
+                </a:solidFill>
+                <a:latin typeface="Cambria" pitchFamily="34" charset="0"/>
+                <a:ea typeface="Cambria" pitchFamily="34" charset="-122"/>
+                <a:cs typeface="Cambria" pitchFamily="34" charset="-120"/>
+              </a:rPr>
+              <a:t>Istilah yang Sudah Dikuasai</a:t>
+            </a:r>
+            <a:endParaRPr lang="en-US" sz="3000" dirty="0"/>
+          </a:p>
+        </p:txBody>
+      </p:sp>
+      <p:sp>
+        <p:nvSpPr>
+          <p:cNvPr id="4" name="Shape 2"/>
+          <p:cNvSpPr/>
+          <p:nvPr/>
+        </p:nvSpPr>
+        <p:spPr>
+          <a:xfrm>
+            <a:off x="548640" y="1691640"/>
+            <a:ext cx="11094415" cy="3877056"/>
+          </a:xfrm>
+          <a:prstGeom prst="roundRect">
+            <a:avLst>
+              <a:gd name="adj" fmla="val 1887"/>
+            </a:avLst>
+          </a:prstGeom>
+          <a:solidFill>
+            <a:srgbClr val="FFFFFF"/>
+          </a:solidFill>
+          <a:ln w="12700">
+            <a:solidFill>
+              <a:srgbClr val="DCE6EC"/>
+            </a:solidFill>
+            <a:prstDash val="solid"/>
+          </a:ln>
+          <a:effectLst>
+            <a:outerShdw sx="100000" sy="100000" kx="0" ky="0" algn="bl" rotWithShape="0" blurRad="101600" dist="25400" dir="5400000">
+              <a:srgbClr val="10243E">
+                <a:alpha val="10000"/>
+              </a:srgbClr>
+            </a:outerShdw>
+          </a:effectLst>
+        </p:spPr>
+      </p:sp>
       <p:graphicFrame>
         <p:nvGraphicFramePr>
-          <p:cNvPr id="11" name="Table 0"/>
+          <p:cNvPr id="12" name="Table 0"/>
           <p:cNvGraphicFramePr>
             <a:graphicFrameLocks noGrp="1"/>
           </p:cNvGraphicFramePr>
@@ -3059,6 +3995,138 @@
                           <a:ea typeface="Courier New" pitchFamily="34" charset="-122"/>
                           <a:cs typeface="Courier New" pitchFamily="34" charset="-120"/>
                         </a:rPr>
+                        <a:t>Seed</a:t>
+                      </a:r>
+                      <a:endParaRPr lang="en-US" sz="1150" dirty="0">
+                        <a:latin typeface="Courier New" charset="0"/>
+                        <a:ea typeface="Courier New" charset="0"/>
+                        <a:cs typeface="Courier New" charset="0"/>
+                      </a:endParaRPr>
+                    </a:p>
+                  </a:txBody>
+                  <a:tcPr marL="91440" marR="91440" marT="45720" marB="45720" anchor="ctr">
+                    <a:lnL w="9525" cap="flat" cmpd="sng" algn="ctr">
+                      <a:solidFill>
+                        <a:srgbClr val="DCE6EC"/>
+                      </a:solidFill>
+                      <a:prstDash val="solid"/>
+                      <a:round/>
+                      <a:headEnd type="none" w="med" len="med"/>
+                      <a:tailEnd type="none" w="med" len="med"/>
+                    </a:lnL>
+                    <a:lnR w="9525" cap="flat" cmpd="sng" algn="ctr">
+                      <a:solidFill>
+                        <a:srgbClr val="DCE6EC"/>
+                      </a:solidFill>
+                      <a:prstDash val="solid"/>
+                      <a:round/>
+                      <a:headEnd type="none" w="med" len="med"/>
+                      <a:tailEnd type="none" w="med" len="med"/>
+                    </a:lnR>
+                    <a:lnT w="9525" cap="flat" cmpd="sng" algn="ctr">
+                      <a:solidFill>
+                        <a:srgbClr val="DCE6EC"/>
+                      </a:solidFill>
+                      <a:prstDash val="solid"/>
+                      <a:round/>
+                      <a:headEnd type="none" w="med" len="med"/>
+                      <a:tailEnd type="none" w="med" len="med"/>
+                    </a:lnT>
+                    <a:lnB w="9525" cap="flat" cmpd="sng" algn="ctr">
+                      <a:solidFill>
+                        <a:srgbClr val="DCE6EC"/>
+                      </a:solidFill>
+                      <a:prstDash val="solid"/>
+                      <a:round/>
+                      <a:headEnd type="none" w="med" len="med"/>
+                      <a:tailEnd type="none" w="med" len="med"/>
+                    </a:lnB>
+                  </a:tcPr>
+                </a:tc>
+                <a:tc>
+                  <a:txBody>
+                    <a:bodyPr/>
+                    <a:lstStyle/>
+                    <a:p>
+                      <a:pPr indent="0" marL="0">
+                        <a:buNone/>
+                      </a:pPr>
+                      <a:r>
+                        <a:rPr lang="en-US" sz="1200" dirty="0">
+                          <a:solidFill>
+                            <a:srgbClr val="10243E"/>
+                          </a:solidFill>
+                          <a:latin typeface="Calibri" pitchFamily="34" charset="0"/>
+                          <a:ea typeface="Calibri" pitchFamily="34" charset="-122"/>
+                          <a:cs typeface="Calibri" pitchFamily="34" charset="-120"/>
+                        </a:rPr>
+                        <a:t>Script yang isi tabel dengan DATA contoh — hapus dulu, baru isi ulang</a:t>
+                      </a:r>
+                      <a:endParaRPr lang="en-US" sz="1200" dirty="0">
+                        <a:latin typeface="Calibri" charset="0"/>
+                        <a:ea typeface="Calibri" charset="0"/>
+                        <a:cs typeface="Calibri" charset="0"/>
+                      </a:endParaRPr>
+                    </a:p>
+                  </a:txBody>
+                  <a:tcPr marL="91440" marR="91440" marT="45720" marB="45720" anchor="ctr">
+                    <a:lnL w="9525" cap="flat" cmpd="sng" algn="ctr">
+                      <a:solidFill>
+                        <a:srgbClr val="DCE6EC"/>
+                      </a:solidFill>
+                      <a:prstDash val="solid"/>
+                      <a:round/>
+                      <a:headEnd type="none" w="med" len="med"/>
+                      <a:tailEnd type="none" w="med" len="med"/>
+                    </a:lnL>
+                    <a:lnR w="9525" cap="flat" cmpd="sng" algn="ctr">
+                      <a:solidFill>
+                        <a:srgbClr val="DCE6EC"/>
+                      </a:solidFill>
+                      <a:prstDash val="solid"/>
+                      <a:round/>
+                      <a:headEnd type="none" w="med" len="med"/>
+                      <a:tailEnd type="none" w="med" len="med"/>
+                    </a:lnR>
+                    <a:lnT w="9525" cap="flat" cmpd="sng" algn="ctr">
+                      <a:solidFill>
+                        <a:srgbClr val="DCE6EC"/>
+                      </a:solidFill>
+                      <a:prstDash val="solid"/>
+                      <a:round/>
+                      <a:headEnd type="none" w="med" len="med"/>
+                      <a:tailEnd type="none" w="med" len="med"/>
+                    </a:lnT>
+                    <a:lnB w="9525" cap="flat" cmpd="sng" algn="ctr">
+                      <a:solidFill>
+                        <a:srgbClr val="DCE6EC"/>
+                      </a:solidFill>
+                      <a:prstDash val="solid"/>
+                      <a:round/>
+                      <a:headEnd type="none" w="med" len="med"/>
+                      <a:tailEnd type="none" w="med" len="med"/>
+                    </a:lnB>
+                  </a:tcPr>
+                </a:tc>
+              </a:tr>
+              <a:tr h="484632">
+                <a:tc>
+                  <a:txBody>
+                    <a:bodyPr/>
+                    <a:lstStyle/>
+                    <a:p>
+                      <a:pPr indent="0" marL="0">
+                        <a:buNone/>
+                      </a:pPr>
+                      <a:r>
+                        <a:rPr lang="en-US" sz="1150" b="1" dirty="0">
+                          <a:solidFill>
+                            <a:srgbClr val="10243E"/>
+                          </a:solidFill>
+                          <a:latin typeface="Courier New" pitchFamily="34" charset="0"/>
+                          <a:ea typeface="Courier New" pitchFamily="34" charset="-122"/>
+                          <a:cs typeface="Courier New" pitchFamily="34" charset="-120"/>
+                        </a:rPr>
                         <a:t>Idempotent</a:t>
                       </a:r>
                       <a:endParaRPr lang="en-US" sz="1150" dirty="0">
@@ -3186,7 +4254,7 @@
         <p:spPr>
           <a:xfrm>
             <a:off x="548640" y="6519672"/>
-            <a:ext cx="7315200" cy="274320"/>
+            <a:ext cx="8229600" cy="274320"/>
           </a:xfrm>
           <a:prstGeom prst="rect">
             <a:avLst/>
@@ -3210,7 +4278,7 @@
                 <a:ea typeface="Calibri" pitchFamily="34" charset="-122"/>
                 <a:cs typeface="Calibri" pitchFamily="34" charset="-120"/>
               </a:rPr>
-              <a:t>db.js, Parameterized Query, &amp; Migration Dasar</a:t>
+              <a:t>db.js, Parameterized Query, Migration &amp; Seeding</a:t>
             </a:r>
             <a:endParaRPr lang="en-US" sz="900" dirty="0"/>
           </a:p>
@@ -3249,7 +4317,7 @@
                 <a:ea typeface="Calibri" pitchFamily="34" charset="-122"/>
                 <a:cs typeface="Calibri" pitchFamily="34" charset="-120"/>
               </a:rPr>
-              <a:t>10</a:t>
+              <a:t>11</a:t>
             </a:r>
             <a:endParaRPr lang="en-US" sz="900" dirty="0"/>
           </a:p>
@@ -3263,9 +4331,9 @@
 </p:sld>
 </file>
 
-<file path=ppt/slides/slide11.xml><?xml version="1.0" encoding="utf-8"?>
+<file path=ppt/slides/slide12.xml><?xml version="1.0" encoding="utf-8"?>
 <p:sld xmlns:a="http://schemas.openxmlformats.org/drawingml/2006/main" xmlns:r="http://schemas.openxmlformats.org/officeDocument/2006/relationships" xmlns:p="http://schemas.openxmlformats.org/presentationml/2006/main">
-  <p:cSld name="Slide 11">
+  <p:cSld name="Slide 12">
     <p:bg>
       <p:bgPr>
         <a:solidFill>
@@ -3393,12 +4461,12 @@
         </p:nvSpPr>
         <p:spPr>
           <a:xfrm>
-            <a:off x="548640" y="1828800"/>
-            <a:ext cx="457200" cy="457200"/>
+            <a:off x="548640" y="1737360"/>
+            <a:ext cx="411480" cy="411480"/>
           </a:xfrm>
           <a:prstGeom prst="roundRect">
             <a:avLst>
-              <a:gd name="adj" fmla="val 16000"/>
+              <a:gd name="adj" fmla="val 17778"/>
             </a:avLst>
           </a:prstGeom>
           <a:solidFill>
@@ -3420,8 +4488,8 @@
         </p:nvSpPr>
         <p:spPr>
           <a:xfrm>
-            <a:off x="548640" y="1828800"/>
-            <a:ext cx="457200" cy="457200"/>
+            <a:off x="548640" y="1737360"/>
+            <a:ext cx="411480" cy="411480"/>
           </a:xfrm>
           <a:prstGeom prst="rect">
             <a:avLst/>
@@ -3437,7 +4505,7 @@
               <a:buNone/>
             </a:pPr>
             <a:r>
-              <a:rPr lang="en-US" sz="1400" b="1" dirty="0">
+              <a:rPr lang="en-US" sz="1300" b="1" dirty="0">
                 <a:solidFill>
                   <a:srgbClr val="2EC4B6"/>
                 </a:solidFill>
@@ -3447,7 +4515,7 @@
               </a:rPr>
               <a:t>1</a:t>
             </a:r>
-            <a:endParaRPr lang="en-US" sz="1400" dirty="0"/>
+            <a:endParaRPr lang="en-US" sz="1300" dirty="0"/>
           </a:p>
         </p:txBody>
       </p:sp>
@@ -3459,8 +4527,8 @@
         </p:nvSpPr>
         <p:spPr>
           <a:xfrm>
-            <a:off x="1188720" y="1810512"/>
-            <a:ext cx="9326880" cy="640080"/>
+            <a:off x="1143000" y="1709928"/>
+            <a:ext cx="9372600" cy="502920"/>
           </a:xfrm>
           <a:prstGeom prst="rect">
             <a:avLst/>
@@ -3476,7 +4544,7 @@
               <a:buNone/>
             </a:pPr>
             <a:r>
-              <a:rPr lang="en-US" sz="1350" dirty="0">
+              <a:rPr lang="en-US" sz="1300" dirty="0">
                 <a:solidFill>
                   <a:srgbClr val="E4EDF3"/>
                 </a:solidFill>
@@ -3486,7 +4554,7 @@
               </a:rPr>
               <a:t>Kenapa pakai Pool, bukan Client satu-satu?</a:t>
             </a:r>
-            <a:endParaRPr lang="en-US" sz="1350" dirty="0"/>
+            <a:endParaRPr lang="en-US" sz="1300" dirty="0"/>
           </a:p>
         </p:txBody>
       </p:sp>
@@ -3498,12 +4566,12 @@
         </p:nvSpPr>
         <p:spPr>
           <a:xfrm>
-            <a:off x="548640" y="2606040"/>
-            <a:ext cx="457200" cy="457200"/>
+            <a:off x="548640" y="2359152"/>
+            <a:ext cx="411480" cy="411480"/>
           </a:xfrm>
           <a:prstGeom prst="roundRect">
             <a:avLst>
-              <a:gd name="adj" fmla="val 16000"/>
+              <a:gd name="adj" fmla="val 17778"/>
             </a:avLst>
           </a:prstGeom>
           <a:solidFill>
@@ -3525,8 +4593,8 @@
         </p:nvSpPr>
         <p:spPr>
           <a:xfrm>
-            <a:off x="548640" y="2606040"/>
-            <a:ext cx="457200" cy="457200"/>
+            <a:off x="548640" y="2359152"/>
+            <a:ext cx="411480" cy="411480"/>
           </a:xfrm>
           <a:prstGeom prst="rect">
             <a:avLst/>
@@ -3542,7 +4610,7 @@
               <a:buNone/>
             </a:pPr>
             <a:r>
-              <a:rPr lang="en-US" sz="1400" b="1" dirty="0">
+              <a:rPr lang="en-US" sz="1300" b="1" dirty="0">
                 <a:solidFill>
                   <a:srgbClr val="2EC4B6"/>
                 </a:solidFill>
@@ -3552,7 +4620,7 @@
               </a:rPr>
               <a:t>2</a:t>
             </a:r>
-            <a:endParaRPr lang="en-US" sz="1400" dirty="0"/>
+            <a:endParaRPr lang="en-US" sz="1300" dirty="0"/>
           </a:p>
         </p:txBody>
       </p:sp>
@@ -3564,8 +4632,8 @@
         </p:nvSpPr>
         <p:spPr>
           <a:xfrm>
-            <a:off x="1188720" y="2587752"/>
-            <a:ext cx="9326880" cy="640080"/>
+            <a:off x="1143000" y="2331720"/>
+            <a:ext cx="9372600" cy="502920"/>
           </a:xfrm>
           <a:prstGeom prst="rect">
             <a:avLst/>
@@ -3581,7 +4649,7 @@
               <a:buNone/>
             </a:pPr>
             <a:r>
-              <a:rPr lang="en-US" sz="1350" dirty="0">
+              <a:rPr lang="en-US" sz="1300" dirty="0">
                 <a:solidFill>
                   <a:srgbClr val="E4EDF3"/>
                 </a:solidFill>
@@ -3591,7 +4659,7 @@
               </a:rPr>
               <a:t>Kenapa WHERE nama = '${namaInput}' berbahaya, dan WHERE nama = $1 aman?</a:t>
             </a:r>
-            <a:endParaRPr lang="en-US" sz="1350" dirty="0"/>
+            <a:endParaRPr lang="en-US" sz="1300" dirty="0"/>
           </a:p>
         </p:txBody>
       </p:sp>
@@ -3603,12 +4671,12 @@
         </p:nvSpPr>
         <p:spPr>
           <a:xfrm>
-            <a:off x="548640" y="3383280"/>
-            <a:ext cx="457200" cy="457200"/>
+            <a:off x="548640" y="2980944"/>
+            <a:ext cx="411480" cy="411480"/>
           </a:xfrm>
           <a:prstGeom prst="roundRect">
             <a:avLst>
-              <a:gd name="adj" fmla="val 16000"/>
+              <a:gd name="adj" fmla="val 17778"/>
             </a:avLst>
           </a:prstGeom>
           <a:solidFill>
@@ -3630,8 +4698,8 @@
         </p:nvSpPr>
         <p:spPr>
           <a:xfrm>
-            <a:off x="548640" y="3383280"/>
-            <a:ext cx="457200" cy="457200"/>
+            <a:off x="548640" y="2980944"/>
+            <a:ext cx="411480" cy="411480"/>
           </a:xfrm>
           <a:prstGeom prst="rect">
             <a:avLst/>
@@ -3647,7 +4715,7 @@
               <a:buNone/>
             </a:pPr>
             <a:r>
-              <a:rPr lang="en-US" sz="1400" b="1" dirty="0">
+              <a:rPr lang="en-US" sz="1300" b="1" dirty="0">
                 <a:solidFill>
                   <a:srgbClr val="2EC4B6"/>
                 </a:solidFill>
@@ -3657,7 +4725,7 @@
               </a:rPr>
               <a:t>3</a:t>
             </a:r>
-            <a:endParaRPr lang="en-US" sz="1400" dirty="0"/>
+            <a:endParaRPr lang="en-US" sz="1300" dirty="0"/>
           </a:p>
         </p:txBody>
       </p:sp>
@@ -3669,8 +4737,8 @@
         </p:nvSpPr>
         <p:spPr>
           <a:xfrm>
-            <a:off x="1188720" y="3364992"/>
-            <a:ext cx="9326880" cy="640080"/>
+            <a:off x="1143000" y="2953512"/>
+            <a:ext cx="9372600" cy="502920"/>
           </a:xfrm>
           <a:prstGeom prst="rect">
             <a:avLst/>
@@ -3686,7 +4754,7 @@
               <a:buNone/>
             </a:pPr>
             <a:r>
-              <a:rPr lang="en-US" sz="1350" dirty="0">
+              <a:rPr lang="en-US" sz="1300" dirty="0">
                 <a:solidFill>
                   <a:srgbClr val="E4EDF3"/>
                 </a:solidFill>
@@ -3696,7 +4764,7 @@
               </a:rPr>
               <a:t>Ada file 002_tambah_kolom.sql dan 001_buat_tabel.sql — mana yang dijalanin duluan, dan kenapa?</a:t>
             </a:r>
-            <a:endParaRPr lang="en-US" sz="1350" dirty="0"/>
+            <a:endParaRPr lang="en-US" sz="1300" dirty="0"/>
           </a:p>
         </p:txBody>
       </p:sp>
@@ -3708,29 +4776,134 @@
         </p:nvSpPr>
         <p:spPr>
           <a:xfrm>
-            <a:off x="548640" y="4434840"/>
-            <a:ext cx="11094415" cy="1417320"/>
+            <a:off x="548640" y="3602736"/>
+            <a:ext cx="411480" cy="411480"/>
           </a:xfrm>
           <a:prstGeom prst="roundRect">
             <a:avLst>
-              <a:gd name="adj" fmla="val 6452"/>
+              <a:gd name="adj" fmla="val 17778"/>
             </a:avLst>
           </a:prstGeom>
           <a:solidFill>
             <a:srgbClr val="17324F"/>
           </a:solidFill>
-          <a:ln/>
-        </p:spPr>
-      </p:sp>
-      <p:sp>
-        <p:nvSpPr>
-          <p:cNvPr id="15" name="Shape 13"/>
-          <p:cNvSpPr/>
-          <p:nvPr/>
-        </p:nvSpPr>
-        <p:spPr>
-          <a:xfrm>
-            <a:off x="822960" y="4709160"/>
+          <a:ln w="12700">
+            <a:solidFill>
+              <a:srgbClr val="2EC4B6"/>
+            </a:solidFill>
+            <a:prstDash val="solid"/>
+          </a:ln>
+        </p:spPr>
+      </p:sp>
+      <p:sp>
+        <p:nvSpPr>
+          <p:cNvPr id="15" name="Text 13"/>
+          <p:cNvSpPr/>
+          <p:nvPr/>
+        </p:nvSpPr>
+        <p:spPr>
+          <a:xfrm>
+            <a:off x="548640" y="3602736"/>
+            <a:ext cx="411480" cy="411480"/>
+          </a:xfrm>
+          <a:prstGeom prst="rect">
+            <a:avLst/>
+          </a:prstGeom>
+          <a:noFill/>
+          <a:ln/>
+        </p:spPr>
+        <p:txBody>
+          <a:bodyPr wrap="square" lIns="0" tIns="0" rIns="0" bIns="0" rtlCol="0" anchor="ctr"/>
+          <a:lstStyle/>
+          <a:p>
+            <a:pPr algn="ctr" indent="0" marL="0">
+              <a:buNone/>
+            </a:pPr>
+            <a:r>
+              <a:rPr lang="en-US" sz="1300" b="1" dirty="0">
+                <a:solidFill>
+                  <a:srgbClr val="2EC4B6"/>
+                </a:solidFill>
+                <a:latin typeface="Calibri" pitchFamily="34" charset="0"/>
+                <a:ea typeface="Calibri" pitchFamily="34" charset="-122"/>
+                <a:cs typeface="Calibri" pitchFamily="34" charset="-120"/>
+              </a:rPr>
+              <a:t>4</a:t>
+            </a:r>
+            <a:endParaRPr lang="en-US" sz="1300" dirty="0"/>
+          </a:p>
+        </p:txBody>
+      </p:sp>
+      <p:sp>
+        <p:nvSpPr>
+          <p:cNvPr id="16" name="Text 14"/>
+          <p:cNvSpPr/>
+          <p:nvPr/>
+        </p:nvSpPr>
+        <p:spPr>
+          <a:xfrm>
+            <a:off x="1143000" y="3575304"/>
+            <a:ext cx="9372600" cy="502920"/>
+          </a:xfrm>
+          <a:prstGeom prst="rect">
+            <a:avLst/>
+          </a:prstGeom>
+          <a:noFill/>
+          <a:ln/>
+        </p:spPr>
+        <p:txBody>
+          <a:bodyPr wrap="square" lIns="0" tIns="0" rIns="0" bIns="0" rtlCol="0" anchor="ctr"/>
+          <a:lstStyle/>
+          <a:p>
+            <a:pPr indent="0" marL="0">
+              <a:buNone/>
+            </a:pPr>
+            <a:r>
+              <a:rPr lang="en-US" sz="1300" dirty="0">
+                <a:solidFill>
+                  <a:srgbClr val="E4EDF3"/>
+                </a:solidFill>
+                <a:latin typeface="Calibri" pitchFamily="34" charset="0"/>
+                <a:ea typeface="Calibri" pitchFamily="34" charset="-122"/>
+                <a:cs typeface="Calibri" pitchFamily="34" charset="-120"/>
+              </a:rPr>
+              <a:t>Kenapa script seed harus DELETE data lama dulu sebelum isi data baru?</a:t>
+            </a:r>
+            <a:endParaRPr lang="en-US" sz="1300" dirty="0"/>
+          </a:p>
+        </p:txBody>
+      </p:sp>
+      <p:sp>
+        <p:nvSpPr>
+          <p:cNvPr id="17" name="Shape 15"/>
+          <p:cNvSpPr/>
+          <p:nvPr/>
+        </p:nvSpPr>
+        <p:spPr>
+          <a:xfrm>
+            <a:off x="548640" y="4343400"/>
+            <a:ext cx="11094415" cy="1371600"/>
+          </a:xfrm>
+          <a:prstGeom prst="roundRect">
+            <a:avLst>
+              <a:gd name="adj" fmla="val 6667"/>
+            </a:avLst>
+          </a:prstGeom>
+          <a:solidFill>
+            <a:srgbClr val="17324F"/>
+          </a:solidFill>
+          <a:ln/>
+        </p:spPr>
+      </p:sp>
+      <p:sp>
+        <p:nvSpPr>
+          <p:cNvPr id="18" name="Shape 16"/>
+          <p:cNvSpPr/>
+          <p:nvPr/>
+        </p:nvSpPr>
+        <p:spPr>
+          <a:xfrm>
+            <a:off x="822960" y="4590288"/>
             <a:ext cx="640080" cy="640080"/>
           </a:xfrm>
           <a:prstGeom prst="ellipse">
@@ -3744,7 +4917,7 @@
       </p:sp>
       <p:pic>
         <p:nvPicPr>
-          <p:cNvPr id="16" name="Image 0" descr="preencoded.png">    </p:cNvPr>
+          <p:cNvPr id="19" name="Image 0" descr="preencoded.png">    </p:cNvPr>
           <p:cNvPicPr>
             <a:picLocks noChangeAspect="1"/>
           </p:cNvPicPr>
@@ -3758,7 +4931,7 @@
         </p:blipFill>
         <p:spPr>
           <a:xfrm>
-            <a:off x="950976" y="4837176"/>
+            <a:off x="950976" y="4718304"/>
             <a:ext cx="384048" cy="384048"/>
           </a:xfrm>
           <a:prstGeom prst="rect">
@@ -3768,13 +4941,13 @@
       </p:pic>
       <p:sp>
         <p:nvSpPr>
-          <p:cNvPr id="17" name="Text 14"/>
-          <p:cNvSpPr/>
-          <p:nvPr/>
-        </p:nvSpPr>
-        <p:spPr>
-          <a:xfrm>
-            <a:off x="1691640" y="4617720"/>
+          <p:cNvPr id="20" name="Text 17"/>
+          <p:cNvSpPr/>
+          <p:nvPr/>
+        </p:nvSpPr>
+        <p:spPr>
+          <a:xfrm>
+            <a:off x="1691640" y="4498848"/>
             <a:ext cx="9601200" cy="411480"/>
           </a:xfrm>
           <a:prstGeom prst="rect">
@@ -3807,14 +4980,14 @@
       </p:sp>
       <p:sp>
         <p:nvSpPr>
-          <p:cNvPr id="18" name="Text 15"/>
-          <p:cNvSpPr/>
-          <p:nvPr/>
-        </p:nvSpPr>
-        <p:spPr>
-          <a:xfrm>
-            <a:off x="1691640" y="5074920"/>
-            <a:ext cx="9601200" cy="640080"/>
+          <p:cNvPr id="21" name="Text 18"/>
+          <p:cNvSpPr/>
+          <p:nvPr/>
+        </p:nvSpPr>
+        <p:spPr>
+          <a:xfrm>
+            <a:off x="1691640" y="4956048"/>
+            <a:ext cx="9601200" cy="685800"/>
           </a:xfrm>
           <a:prstGeom prst="rect">
             <a:avLst/>
@@ -3841,7 +5014,7 @@
                 <a:ea typeface="Calibri" pitchFamily="34" charset="-122"/>
                 <a:cs typeface="Calibri" pitchFamily="34" charset="-120"/>
               </a:rPr>
-              <a:t>Test bakal beneran jalanin migration &amp; query kamu ke PostgreSQL asli, termasuk nyoba input yang isinya tanda kutip buat mastiin placeholder-nya beneran dipakai.</a:t>
+              <a:t>Test bakal beneran jalanin migration, query, &amp; seed kamu ke PostgreSQL asli, termasuk nyoba input yang isinya tanda kutip buat mastiin placeholder-nya beneran dipakai.</a:t>
             </a:r>
             <a:endParaRPr lang="en-US" sz="1250" dirty="0"/>
           </a:p>
@@ -3849,13 +5022,13 @@
       </p:sp>
       <p:sp>
         <p:nvSpPr>
-          <p:cNvPr id="19" name="Text 16"/>
-          <p:cNvSpPr/>
-          <p:nvPr/>
-        </p:nvSpPr>
-        <p:spPr>
-          <a:xfrm>
-            <a:off x="548640" y="6172200"/>
+          <p:cNvPr id="22" name="Text 19"/>
+          <p:cNvSpPr/>
+          <p:nvPr/>
+        </p:nvSpPr>
+        <p:spPr>
+          <a:xfrm>
+            <a:off x="548640" y="5989320"/>
             <a:ext cx="11094415" cy="365760"/>
           </a:xfrm>
           <a:prstGeom prst="rect">
@@ -3880,7 +5053,7 @@
                 <a:ea typeface="Calibri" pitchFamily="34" charset="-122"/>
                 <a:cs typeface="Calibri" pitchFamily="34" charset="-120"/>
               </a:rPr>
-              <a:t>Modul lanjutan: Phase 4 ROADMAP — refactor CRUD API dari array-in-memory ke query PostgreSQL beneran, pakai db.js &amp; migration ini.</a:t>
+              <a:t>Modul lanjutan: Phase 4 ROADMAP — refactor CRUD API dari array-in-memory ke query PostgreSQL beneran, pakai db.js, migration, &amp; seed ini.</a:t>
             </a:r>
             <a:endParaRPr lang="en-US" sz="1150" dirty="0"/>
           </a:p>
@@ -4441,7 +5614,7 @@
         <p:spPr>
           <a:xfrm>
             <a:off x="548640" y="6519672"/>
-            <a:ext cx="7315200" cy="274320"/>
+            <a:ext cx="8229600" cy="274320"/>
           </a:xfrm>
           <a:prstGeom prst="rect">
             <a:avLst/>
@@ -4465,7 +5638,7 @@
                 <a:ea typeface="Calibri" pitchFamily="34" charset="-122"/>
                 <a:cs typeface="Calibri" pitchFamily="34" charset="-120"/>
               </a:rPr>
-              <a:t>db.js, Parameterized Query, &amp; Migration Dasar</a:t>
+              <a:t>db.js, Parameterized Query, Migration &amp; Seeding</a:t>
             </a:r>
             <a:endParaRPr lang="en-US" sz="900" dirty="0"/>
           </a:p>
@@ -5130,7 +6303,7 @@
         <p:spPr>
           <a:xfrm>
             <a:off x="548640" y="6519672"/>
-            <a:ext cx="7315200" cy="274320"/>
+            <a:ext cx="8229600" cy="274320"/>
           </a:xfrm>
           <a:prstGeom prst="rect">
             <a:avLst/>
@@ -5154,7 +6327,7 @@
                 <a:ea typeface="Calibri" pitchFamily="34" charset="-122"/>
                 <a:cs typeface="Calibri" pitchFamily="34" charset="-120"/>
               </a:rPr>
-              <a:t>db.js, Parameterized Query, &amp; Migration Dasar</a:t>
+              <a:t>db.js, Parameterized Query, Migration &amp; Seeding</a:t>
             </a:r>
             <a:endParaRPr lang="en-US" sz="900" dirty="0"/>
           </a:p>
@@ -5751,7 +6924,7 @@
         <p:spPr>
           <a:xfrm>
             <a:off x="548640" y="6519672"/>
-            <a:ext cx="7315200" cy="274320"/>
+            <a:ext cx="8229600" cy="274320"/>
           </a:xfrm>
           <a:prstGeom prst="rect">
             <a:avLst/>
@@ -5775,7 +6948,7 @@
                 <a:ea typeface="Calibri" pitchFamily="34" charset="-122"/>
                 <a:cs typeface="Calibri" pitchFamily="34" charset="-120"/>
               </a:rPr>
-              <a:t>db.js, Parameterized Query, &amp; Migration Dasar</a:t>
+              <a:t>db.js, Parameterized Query, Migration &amp; Seeding</a:t>
             </a:r>
             <a:endParaRPr lang="en-US" sz="900" dirty="0"/>
           </a:p>
@@ -6417,7 +7590,7 @@
         <p:spPr>
           <a:xfrm>
             <a:off x="548640" y="6519672"/>
-            <a:ext cx="7315200" cy="274320"/>
+            <a:ext cx="8229600" cy="274320"/>
           </a:xfrm>
           <a:prstGeom prst="rect">
             <a:avLst/>
@@ -6441,7 +7614,7 @@
                 <a:ea typeface="Calibri" pitchFamily="34" charset="-122"/>
                 <a:cs typeface="Calibri" pitchFamily="34" charset="-120"/>
               </a:rPr>
-              <a:t>db.js, Parameterized Query, &amp; Migration Dasar</a:t>
+              <a:t>db.js, Parameterized Query, Migration &amp; Seeding</a:t>
             </a:r>
             <a:endParaRPr lang="en-US" sz="900" dirty="0"/>
           </a:p>
@@ -6955,7 +8128,7 @@
         <p:spPr>
           <a:xfrm>
             <a:off x="548640" y="6519672"/>
-            <a:ext cx="7315200" cy="274320"/>
+            <a:ext cx="8229600" cy="274320"/>
           </a:xfrm>
           <a:prstGeom prst="rect">
             <a:avLst/>
@@ -6979,7 +8152,7 @@
                 <a:ea typeface="Calibri" pitchFamily="34" charset="-122"/>
                 <a:cs typeface="Calibri" pitchFamily="34" charset="-120"/>
               </a:rPr>
-              <a:t>db.js, Parameterized Query, &amp; Migration Dasar</a:t>
+              <a:t>db.js, Parameterized Query, Migration &amp; Seeding</a:t>
             </a:r>
             <a:endParaRPr lang="en-US" sz="900" dirty="0"/>
           </a:p>
@@ -7420,7 +8593,7 @@
         <p:spPr>
           <a:xfrm>
             <a:off x="548640" y="6519672"/>
-            <a:ext cx="7315200" cy="274320"/>
+            <a:ext cx="8229600" cy="274320"/>
           </a:xfrm>
           <a:prstGeom prst="rect">
             <a:avLst/>
@@ -7444,7 +8617,7 @@
                 <a:ea typeface="Calibri" pitchFamily="34" charset="-122"/>
                 <a:cs typeface="Calibri" pitchFamily="34" charset="-120"/>
               </a:rPr>
-              <a:t>db.js, Parameterized Query, &amp; Migration Dasar</a:t>
+              <a:t>db.js, Parameterized Query, Migration &amp; Seeding</a:t>
             </a:r>
             <a:endParaRPr lang="en-US" sz="900" dirty="0"/>
           </a:p>
@@ -8415,7 +9588,7 @@
         <p:spPr>
           <a:xfrm>
             <a:off x="548640" y="6519672"/>
-            <a:ext cx="7315200" cy="274320"/>
+            <a:ext cx="8229600" cy="274320"/>
           </a:xfrm>
           <a:prstGeom prst="rect">
             <a:avLst/>
@@ -8439,7 +9612,7 @@
                 <a:ea typeface="Calibri" pitchFamily="34" charset="-122"/>
                 <a:cs typeface="Calibri" pitchFamily="34" charset="-120"/>
               </a:rPr>
-              <a:t>db.js, Parameterized Query, &amp; Migration Dasar</a:t>
+              <a:t>db.js, Parameterized Query, Migration &amp; Seeding</a:t>
             </a:r>
             <a:endParaRPr lang="en-US" sz="900" dirty="0"/>
           </a:p>
@@ -9104,7 +10277,7 @@
         <p:spPr>
           <a:xfrm>
             <a:off x="548640" y="6519672"/>
-            <a:ext cx="7315200" cy="274320"/>
+            <a:ext cx="8229600" cy="274320"/>
           </a:xfrm>
           <a:prstGeom prst="rect">
             <a:avLst/>
@@ -9128,7 +10301,7 @@
                 <a:ea typeface="Calibri" pitchFamily="34" charset="-122"/>
                 <a:cs typeface="Calibri" pitchFamily="34" charset="-120"/>
               </a:rPr>
-              <a:t>db.js, Parameterized Query, &amp; Migration Dasar</a:t>
+              <a:t>db.js, Parameterized Query, Migration &amp; Seeding</a:t>
             </a:r>
             <a:endParaRPr lang="en-US" sz="900" dirty="0"/>
           </a:p>

</xml_diff>